<commit_message>
Slide 3: replace abstract pipeline with narrative + 3 dataset cards explaining what each trains
</commit_message>
<xml_diff>
--- a/presentation/slides-editable.pptx
+++ b/presentation/slides-editable.pptx
@@ -5070,21 +5070,60 @@
                 </a:solidFill>
                 <a:latin typeface="Calibri"/>
               </a:rPr>
-              <a:t>From 10 public datasets to three task corpora</a:t>
-            </a:r>
-          </a:p>
-        </p:txBody>
-      </p:sp>
-      <p:sp>
-        <p:nvSpPr>
-          <p:cNvPr id="5" name="Rounded Rectangle 4"/>
+              <a:t>We curated three purpose-built datasets, one per model</a:t>
+            </a:r>
+          </a:p>
+        </p:txBody>
+      </p:sp>
+      <p:sp>
+        <p:nvSpPr>
+          <p:cNvPr id="5" name="TextBox 4"/>
+          <p:cNvSpPr txBox="1"/>
+          <p:nvPr/>
+        </p:nvSpPr>
+        <p:spPr>
+          <a:xfrm>
+            <a:off x="758952" y="1828800"/>
+            <a:ext cx="10671048" cy="457200"/>
+          </a:xfrm>
+          <a:prstGeom prst="rect">
+            <a:avLst/>
+          </a:prstGeom>
+          <a:noFill/>
+        </p:spPr>
+        <p:txBody>
+          <a:bodyPr wrap="square" lIns="0" rIns="0" tIns="0" bIns="0" anchor="t">
+            <a:spAutoFit/>
+          </a:bodyPr>
+          <a:lstStyle/>
+          <a:p>
+            <a:pPr algn="l">
+              <a:lnSpc>
+                <a:spcPct val="150000"/>
+              </a:lnSpc>
+            </a:pPr>
+            <a:r>
+              <a:rPr sz="1200" b="0">
+                <a:solidFill>
+                  <a:srgbClr val="0E0E0E"/>
+                </a:solidFill>
+                <a:latin typeface="Calibri"/>
+              </a:rPr>
+              <a:t>Building a corpus from scratch was not feasible. Instead, we aggregated 10 public text-to-SQL datasets, unified their schemas, removed duplicates by question hashing, and filtered out examples longer than 1,024 tokens. From the same merged corpus we then derived two more datasets — one for chart reasoning, one for SVG rendering — to train each specialist on its own task.</a:t>
+            </a:r>
+          </a:p>
+        </p:txBody>
+      </p:sp>
+      <p:sp>
+        <p:nvSpPr>
+          <p:cNvPr id="6" name="Rounded Rectangle 5"/>
           <p:cNvSpPr/>
           <p:nvPr/>
         </p:nvSpPr>
         <p:spPr>
           <a:xfrm>
-            <a:off x="586587" y="2011680"/>
-            <a:ext cx="3520440" cy="1097280"/>
+            <a:off x="495147" y="3200400"/>
+            <a:ext cx="3611880" cy="3017520"/>
           </a:xfrm>
           <a:prstGeom prst="roundRect">
             <a:avLst>
@@ -5125,92 +5164,369 @@
       </p:sp>
       <p:sp>
         <p:nvSpPr>
-          <p:cNvPr id="6" name="TextBox 5"/>
-          <p:cNvSpPr txBox="1"/>
-          <p:nvPr/>
-        </p:nvSpPr>
-        <p:spPr>
-          <a:xfrm>
-            <a:off x="586587" y="2148840"/>
-            <a:ext cx="3520440" cy="548640"/>
-          </a:xfrm>
-          <a:prstGeom prst="rect">
-            <a:avLst/>
-          </a:prstGeom>
-          <a:noFill/>
-        </p:spPr>
-        <p:txBody>
-          <a:bodyPr wrap="square" lIns="0" rIns="0" tIns="0" bIns="0" anchor="t">
-            <a:spAutoFit/>
-          </a:bodyPr>
-          <a:lstStyle/>
-          <a:p>
-            <a:pPr algn="ctr">
-              <a:lnSpc>
-                <a:spcPct val="140000"/>
-              </a:lnSpc>
-            </a:pPr>
-            <a:r>
-              <a:rPr sz="3600" b="1">
+          <p:cNvPr id="7" name="Rectangle 6"/>
+          <p:cNvSpPr/>
+          <p:nvPr/>
+        </p:nvSpPr>
+        <p:spPr>
+          <a:xfrm>
+            <a:off x="678027" y="3364992"/>
+            <a:ext cx="365760" cy="45720"/>
+          </a:xfrm>
+          <a:prstGeom prst="rect">
+            <a:avLst/>
+          </a:prstGeom>
+          <a:solidFill>
+            <a:srgbClr val="C96442"/>
+          </a:solidFill>
+          <a:ln>
+            <a:noFill/>
+          </a:ln>
+        </p:spPr>
+        <p:style>
+          <a:lnRef idx="1">
+            <a:schemeClr val="accent1"/>
+          </a:lnRef>
+          <a:fillRef idx="3">
+            <a:schemeClr val="accent1"/>
+          </a:fillRef>
+          <a:effectRef idx="2">
+            <a:schemeClr val="accent1"/>
+          </a:effectRef>
+          <a:fontRef idx="minor">
+            <a:schemeClr val="lt1"/>
+          </a:fontRef>
+        </p:style>
+        <p:txBody>
+          <a:bodyPr rtlCol="0" anchor="ctr"/>
+          <a:lstStyle/>
+          <a:p>
+            <a:pPr algn="ctr"/>
+          </a:p>
+        </p:txBody>
+      </p:sp>
+      <p:sp>
+        <p:nvSpPr>
+          <p:cNvPr id="8" name="TextBox 7"/>
+          <p:cNvSpPr txBox="1"/>
+          <p:nvPr/>
+        </p:nvSpPr>
+        <p:spPr>
+          <a:xfrm>
+            <a:off x="678027" y="3493008"/>
+            <a:ext cx="3246120" cy="228600"/>
+          </a:xfrm>
+          <a:prstGeom prst="rect">
+            <a:avLst/>
+          </a:prstGeom>
+          <a:noFill/>
+        </p:spPr>
+        <p:txBody>
+          <a:bodyPr wrap="square" lIns="0" rIns="0" tIns="0" bIns="0" anchor="t">
+            <a:spAutoFit/>
+          </a:bodyPr>
+          <a:lstStyle/>
+          <a:p>
+            <a:pPr algn="l">
+              <a:lnSpc>
+                <a:spcPct val="140000"/>
+              </a:lnSpc>
+            </a:pPr>
+            <a:r>
+              <a:rPr sz="900" b="1">
+                <a:solidFill>
+                  <a:srgbClr val="C96442"/>
+                </a:solidFill>
+                <a:latin typeface="Calibri"/>
+              </a:rPr>
+              <a:t>DATASET · 01</a:t>
+            </a:r>
+          </a:p>
+        </p:txBody>
+      </p:sp>
+      <p:sp>
+        <p:nvSpPr>
+          <p:cNvPr id="9" name="TextBox 8"/>
+          <p:cNvSpPr txBox="1"/>
+          <p:nvPr/>
+        </p:nvSpPr>
+        <p:spPr>
+          <a:xfrm>
+            <a:off x="678027" y="3749040"/>
+            <a:ext cx="3246120" cy="365760"/>
+          </a:xfrm>
+          <a:prstGeom prst="rect">
+            <a:avLst/>
+          </a:prstGeom>
+          <a:noFill/>
+        </p:spPr>
+        <p:txBody>
+          <a:bodyPr wrap="square" lIns="0" rIns="0" tIns="0" bIns="0" anchor="t">
+            <a:spAutoFit/>
+          </a:bodyPr>
+          <a:lstStyle/>
+          <a:p>
+            <a:pPr algn="l">
+              <a:lnSpc>
+                <a:spcPct val="140000"/>
+              </a:lnSpc>
+            </a:pPr>
+            <a:r>
+              <a:rPr sz="1400" b="1">
                 <a:solidFill>
                   <a:srgbClr val="0E0E0E"/>
                 </a:solidFill>
-                <a:latin typeface="Calibri"/>
-              </a:rPr>
-              <a:t>1.2M</a:t>
-            </a:r>
-          </a:p>
-        </p:txBody>
-      </p:sp>
-      <p:sp>
-        <p:nvSpPr>
-          <p:cNvPr id="7" name="TextBox 6"/>
-          <p:cNvSpPr txBox="1"/>
-          <p:nvPr/>
-        </p:nvSpPr>
-        <p:spPr>
-          <a:xfrm>
-            <a:off x="586587" y="2697480"/>
-            <a:ext cx="3520440" cy="365760"/>
-          </a:xfrm>
-          <a:prstGeom prst="rect">
-            <a:avLst/>
-          </a:prstGeom>
-          <a:noFill/>
-        </p:spPr>
-        <p:txBody>
-          <a:bodyPr wrap="square" lIns="0" rIns="0" tIns="0" bIns="0" anchor="t">
-            <a:spAutoFit/>
-          </a:bodyPr>
-          <a:lstStyle/>
-          <a:p>
-            <a:pPr algn="ctr">
-              <a:lnSpc>
-                <a:spcPct val="140000"/>
-              </a:lnSpc>
-            </a:pPr>
-            <a:r>
-              <a:rPr sz="1100" b="0">
+                <a:latin typeface="Menlo"/>
+              </a:rPr>
+              <a:t>text-to-sql-mix-v2</a:t>
+            </a:r>
+          </a:p>
+        </p:txBody>
+      </p:sp>
+      <p:sp>
+        <p:nvSpPr>
+          <p:cNvPr id="10" name="TextBox 9"/>
+          <p:cNvSpPr txBox="1"/>
+          <p:nvPr/>
+        </p:nvSpPr>
+        <p:spPr>
+          <a:xfrm>
+            <a:off x="678027" y="4160520"/>
+            <a:ext cx="3246120" cy="548640"/>
+          </a:xfrm>
+          <a:prstGeom prst="rect">
+            <a:avLst/>
+          </a:prstGeom>
+          <a:noFill/>
+        </p:spPr>
+        <p:txBody>
+          <a:bodyPr wrap="square" lIns="0" rIns="0" tIns="0" bIns="0" anchor="t">
+            <a:spAutoFit/>
+          </a:bodyPr>
+          <a:lstStyle/>
+          <a:p>
+            <a:pPr algn="l">
+              <a:lnSpc>
+                <a:spcPct val="140000"/>
+              </a:lnSpc>
+            </a:pPr>
+            <a:r>
+              <a:rPr sz="2800" b="1">
+                <a:solidFill>
+                  <a:srgbClr val="0E0E0E"/>
+                </a:solidFill>
+                <a:latin typeface="Calibri"/>
+              </a:rPr>
+              <a:t>761,155</a:t>
+            </a:r>
+          </a:p>
+        </p:txBody>
+      </p:sp>
+      <p:sp>
+        <p:nvSpPr>
+          <p:cNvPr id="11" name="TextBox 10"/>
+          <p:cNvSpPr txBox="1"/>
+          <p:nvPr/>
+        </p:nvSpPr>
+        <p:spPr>
+          <a:xfrm>
+            <a:off x="678027" y="4709160"/>
+            <a:ext cx="3246120" cy="274320"/>
+          </a:xfrm>
+          <a:prstGeom prst="rect">
+            <a:avLst/>
+          </a:prstGeom>
+          <a:noFill/>
+        </p:spPr>
+        <p:txBody>
+          <a:bodyPr wrap="square" lIns="0" rIns="0" tIns="0" bIns="0" anchor="t">
+            <a:spAutoFit/>
+          </a:bodyPr>
+          <a:lstStyle/>
+          <a:p>
+            <a:pPr algn="l">
+              <a:lnSpc>
+                <a:spcPct val="140000"/>
+              </a:lnSpc>
+            </a:pPr>
+            <a:r>
+              <a:rPr sz="800" b="0">
                 <a:solidFill>
                   <a:srgbClr val="5A5A5A"/>
                 </a:solidFill>
                 <a:latin typeface="Calibri"/>
               </a:rPr>
-              <a:t>Raw rows from 10 public sources</a:t>
-            </a:r>
-          </a:p>
-        </p:txBody>
-      </p:sp>
-      <p:sp>
-        <p:nvSpPr>
-          <p:cNvPr id="8" name="Rounded Rectangle 7"/>
+              <a:t>ROWS</a:t>
+            </a:r>
+          </a:p>
+        </p:txBody>
+      </p:sp>
+      <p:sp>
+        <p:nvSpPr>
+          <p:cNvPr id="12" name="TextBox 11"/>
+          <p:cNvSpPr txBox="1"/>
+          <p:nvPr/>
+        </p:nvSpPr>
+        <p:spPr>
+          <a:xfrm>
+            <a:off x="678027" y="5029200"/>
+            <a:ext cx="3246120" cy="274320"/>
+          </a:xfrm>
+          <a:prstGeom prst="rect">
+            <a:avLst/>
+          </a:prstGeom>
+          <a:noFill/>
+        </p:spPr>
+        <p:txBody>
+          <a:bodyPr wrap="square" lIns="0" rIns="0" tIns="0" bIns="0" anchor="t">
+            <a:spAutoFit/>
+          </a:bodyPr>
+          <a:lstStyle/>
+          <a:p>
+            <a:pPr algn="l">
+              <a:lnSpc>
+                <a:spcPct val="140000"/>
+              </a:lnSpc>
+            </a:pPr>
+            <a:r>
+              <a:rPr sz="800" b="1">
+                <a:solidFill>
+                  <a:srgbClr val="5A5A5A"/>
+                </a:solidFill>
+                <a:latin typeface="Calibri"/>
+              </a:rPr>
+              <a:t>TRAINS</a:t>
+            </a:r>
+          </a:p>
+        </p:txBody>
+      </p:sp>
+      <p:sp>
+        <p:nvSpPr>
+          <p:cNvPr id="13" name="TextBox 12"/>
+          <p:cNvSpPr txBox="1"/>
+          <p:nvPr/>
+        </p:nvSpPr>
+        <p:spPr>
+          <a:xfrm>
+            <a:off x="678027" y="5230368"/>
+            <a:ext cx="3246120" cy="365760"/>
+          </a:xfrm>
+          <a:prstGeom prst="rect">
+            <a:avLst/>
+          </a:prstGeom>
+          <a:noFill/>
+        </p:spPr>
+        <p:txBody>
+          <a:bodyPr wrap="square" lIns="0" rIns="0" tIns="0" bIns="0" anchor="t">
+            <a:spAutoFit/>
+          </a:bodyPr>
+          <a:lstStyle/>
+          <a:p>
+            <a:pPr algn="l">
+              <a:lnSpc>
+                <a:spcPct val="140000"/>
+              </a:lnSpc>
+            </a:pPr>
+            <a:r>
+              <a:rPr sz="1100" b="1">
+                <a:solidFill>
+                  <a:srgbClr val="0E0E0E"/>
+                </a:solidFill>
+                <a:latin typeface="Calibri"/>
+              </a:rPr>
+              <a:t>SQL Generator · Qwen 7B</a:t>
+            </a:r>
+          </a:p>
+        </p:txBody>
+      </p:sp>
+      <p:sp>
+        <p:nvSpPr>
+          <p:cNvPr id="14" name="TextBox 13"/>
+          <p:cNvSpPr txBox="1"/>
+          <p:nvPr/>
+        </p:nvSpPr>
+        <p:spPr>
+          <a:xfrm>
+            <a:off x="678027" y="5532120"/>
+            <a:ext cx="3246120" cy="457200"/>
+          </a:xfrm>
+          <a:prstGeom prst="rect">
+            <a:avLst/>
+          </a:prstGeom>
+          <a:noFill/>
+        </p:spPr>
+        <p:txBody>
+          <a:bodyPr wrap="square" lIns="0" rIns="0" tIns="0" bIns="0" anchor="t">
+            <a:spAutoFit/>
+          </a:bodyPr>
+          <a:lstStyle/>
+          <a:p>
+            <a:pPr algn="l">
+              <a:lnSpc>
+                <a:spcPct val="140000"/>
+              </a:lnSpc>
+            </a:pPr>
+            <a:r>
+              <a:rPr sz="1000" b="0">
+                <a:solidFill>
+                  <a:srgbClr val="0E0E0E"/>
+                </a:solidFill>
+                <a:latin typeface="Calibri"/>
+              </a:rPr>
+              <a:t>Natural-language question + schema → valid SQL query.</a:t>
+            </a:r>
+          </a:p>
+        </p:txBody>
+      </p:sp>
+      <p:sp>
+        <p:nvSpPr>
+          <p:cNvPr id="15" name="TextBox 14"/>
+          <p:cNvSpPr txBox="1"/>
+          <p:nvPr/>
+        </p:nvSpPr>
+        <p:spPr>
+          <a:xfrm>
+            <a:off x="678027" y="5897880"/>
+            <a:ext cx="3246120" cy="457200"/>
+          </a:xfrm>
+          <a:prstGeom prst="rect">
+            <a:avLst/>
+          </a:prstGeom>
+          <a:noFill/>
+        </p:spPr>
+        <p:txBody>
+          <a:bodyPr wrap="square" lIns="0" rIns="0" tIns="0" bIns="0" anchor="t">
+            <a:spAutoFit/>
+          </a:bodyPr>
+          <a:lstStyle/>
+          <a:p>
+            <a:pPr algn="l">
+              <a:lnSpc>
+                <a:spcPct val="135000"/>
+              </a:lnSpc>
+            </a:pPr>
+            <a:r>
+              <a:rPr sz="900" b="0">
+                <a:solidFill>
+                  <a:srgbClr val="5A5A5A"/>
+                </a:solidFill>
+                <a:latin typeface="Calibri"/>
+              </a:rPr>
+              <a:t>Merged from 10 public datasets (sql-create-context, gretel, knowsql, NSText2SQL, Spider, WikiSQL, etc.). Schemas unified into a 7-column canonical format.</a:t>
+            </a:r>
+          </a:p>
+        </p:txBody>
+      </p:sp>
+      <p:sp>
+        <p:nvSpPr>
+          <p:cNvPr id="16" name="Rounded Rectangle 15"/>
           <p:cNvSpPr/>
           <p:nvPr/>
         </p:nvSpPr>
         <p:spPr>
           <a:xfrm>
-            <a:off x="4335627" y="2011680"/>
-            <a:ext cx="3520440" cy="1097280"/>
+            <a:off x="4289907" y="3200400"/>
+            <a:ext cx="3611880" cy="3017520"/>
           </a:xfrm>
           <a:prstGeom prst="roundRect">
             <a:avLst>
@@ -5251,92 +5567,369 @@
       </p:sp>
       <p:sp>
         <p:nvSpPr>
-          <p:cNvPr id="9" name="TextBox 8"/>
-          <p:cNvSpPr txBox="1"/>
-          <p:nvPr/>
-        </p:nvSpPr>
-        <p:spPr>
-          <a:xfrm>
-            <a:off x="4335627" y="2148840"/>
-            <a:ext cx="3520440" cy="548640"/>
-          </a:xfrm>
-          <a:prstGeom prst="rect">
-            <a:avLst/>
-          </a:prstGeom>
-          <a:noFill/>
-        </p:spPr>
-        <p:txBody>
-          <a:bodyPr wrap="square" lIns="0" rIns="0" tIns="0" bIns="0" anchor="t">
-            <a:spAutoFit/>
-          </a:bodyPr>
-          <a:lstStyle/>
-          <a:p>
-            <a:pPr algn="ctr">
-              <a:lnSpc>
-                <a:spcPct val="140000"/>
-              </a:lnSpc>
-            </a:pPr>
-            <a:r>
-              <a:rPr sz="3600" b="1">
+          <p:cNvPr id="17" name="Rectangle 16"/>
+          <p:cNvSpPr/>
+          <p:nvPr/>
+        </p:nvSpPr>
+        <p:spPr>
+          <a:xfrm>
+            <a:off x="4472787" y="3364992"/>
+            <a:ext cx="365760" cy="45720"/>
+          </a:xfrm>
+          <a:prstGeom prst="rect">
+            <a:avLst/>
+          </a:prstGeom>
+          <a:solidFill>
+            <a:srgbClr val="C96442"/>
+          </a:solidFill>
+          <a:ln>
+            <a:noFill/>
+          </a:ln>
+        </p:spPr>
+        <p:style>
+          <a:lnRef idx="1">
+            <a:schemeClr val="accent1"/>
+          </a:lnRef>
+          <a:fillRef idx="3">
+            <a:schemeClr val="accent1"/>
+          </a:fillRef>
+          <a:effectRef idx="2">
+            <a:schemeClr val="accent1"/>
+          </a:effectRef>
+          <a:fontRef idx="minor">
+            <a:schemeClr val="lt1"/>
+          </a:fontRef>
+        </p:style>
+        <p:txBody>
+          <a:bodyPr rtlCol="0" anchor="ctr"/>
+          <a:lstStyle/>
+          <a:p>
+            <a:pPr algn="ctr"/>
+          </a:p>
+        </p:txBody>
+      </p:sp>
+      <p:sp>
+        <p:nvSpPr>
+          <p:cNvPr id="18" name="TextBox 17"/>
+          <p:cNvSpPr txBox="1"/>
+          <p:nvPr/>
+        </p:nvSpPr>
+        <p:spPr>
+          <a:xfrm>
+            <a:off x="4472787" y="3493008"/>
+            <a:ext cx="3246120" cy="228600"/>
+          </a:xfrm>
+          <a:prstGeom prst="rect">
+            <a:avLst/>
+          </a:prstGeom>
+          <a:noFill/>
+        </p:spPr>
+        <p:txBody>
+          <a:bodyPr wrap="square" lIns="0" rIns="0" tIns="0" bIns="0" anchor="t">
+            <a:spAutoFit/>
+          </a:bodyPr>
+          <a:lstStyle/>
+          <a:p>
+            <a:pPr algn="l">
+              <a:lnSpc>
+                <a:spcPct val="140000"/>
+              </a:lnSpc>
+            </a:pPr>
+            <a:r>
+              <a:rPr sz="900" b="1">
+                <a:solidFill>
+                  <a:srgbClr val="C96442"/>
+                </a:solidFill>
+                <a:latin typeface="Calibri"/>
+              </a:rPr>
+              <a:t>DATASET · 02</a:t>
+            </a:r>
+          </a:p>
+        </p:txBody>
+      </p:sp>
+      <p:sp>
+        <p:nvSpPr>
+          <p:cNvPr id="19" name="TextBox 18"/>
+          <p:cNvSpPr txBox="1"/>
+          <p:nvPr/>
+        </p:nvSpPr>
+        <p:spPr>
+          <a:xfrm>
+            <a:off x="4472787" y="3749040"/>
+            <a:ext cx="3246120" cy="365760"/>
+          </a:xfrm>
+          <a:prstGeom prst="rect">
+            <a:avLst/>
+          </a:prstGeom>
+          <a:noFill/>
+        </p:spPr>
+        <p:txBody>
+          <a:bodyPr wrap="square" lIns="0" rIns="0" tIns="0" bIns="0" anchor="t">
+            <a:spAutoFit/>
+          </a:bodyPr>
+          <a:lstStyle/>
+          <a:p>
+            <a:pPr algn="l">
+              <a:lnSpc>
+                <a:spcPct val="140000"/>
+              </a:lnSpc>
+            </a:pPr>
+            <a:r>
+              <a:rPr sz="1400" b="1">
                 <a:solidFill>
                   <a:srgbClr val="0E0E0E"/>
                 </a:solidFill>
-                <a:latin typeface="Calibri"/>
-              </a:rPr>
-              <a:t>723k</a:t>
-            </a:r>
-          </a:p>
-        </p:txBody>
-      </p:sp>
-      <p:sp>
-        <p:nvSpPr>
-          <p:cNvPr id="10" name="TextBox 9"/>
-          <p:cNvSpPr txBox="1"/>
-          <p:nvPr/>
-        </p:nvSpPr>
-        <p:spPr>
-          <a:xfrm>
-            <a:off x="4335627" y="2697480"/>
-            <a:ext cx="3520440" cy="365760"/>
-          </a:xfrm>
-          <a:prstGeom prst="rect">
-            <a:avLst/>
-          </a:prstGeom>
-          <a:noFill/>
-        </p:spPr>
-        <p:txBody>
-          <a:bodyPr wrap="square" lIns="0" rIns="0" tIns="0" bIns="0" anchor="t">
-            <a:spAutoFit/>
-          </a:bodyPr>
-          <a:lstStyle/>
-          <a:p>
-            <a:pPr algn="ctr">
-              <a:lnSpc>
-                <a:spcPct val="140000"/>
-              </a:lnSpc>
-            </a:pPr>
-            <a:r>
-              <a:rPr sz="1100" b="0">
+                <a:latin typeface="Menlo"/>
+              </a:rPr>
+              <a:t>chart-reasoning-mix-v1</a:t>
+            </a:r>
+          </a:p>
+        </p:txBody>
+      </p:sp>
+      <p:sp>
+        <p:nvSpPr>
+          <p:cNvPr id="20" name="TextBox 19"/>
+          <p:cNvSpPr txBox="1"/>
+          <p:nvPr/>
+        </p:nvSpPr>
+        <p:spPr>
+          <a:xfrm>
+            <a:off x="4472787" y="4160520"/>
+            <a:ext cx="3246120" cy="548640"/>
+          </a:xfrm>
+          <a:prstGeom prst="rect">
+            <a:avLst/>
+          </a:prstGeom>
+          <a:noFill/>
+        </p:spPr>
+        <p:txBody>
+          <a:bodyPr wrap="square" lIns="0" rIns="0" tIns="0" bIns="0" anchor="t">
+            <a:spAutoFit/>
+          </a:bodyPr>
+          <a:lstStyle/>
+          <a:p>
+            <a:pPr algn="l">
+              <a:lnSpc>
+                <a:spcPct val="140000"/>
+              </a:lnSpc>
+            </a:pPr>
+            <a:r>
+              <a:rPr sz="2800" b="1">
+                <a:solidFill>
+                  <a:srgbClr val="0E0E0E"/>
+                </a:solidFill>
+                <a:latin typeface="Calibri"/>
+              </a:rPr>
+              <a:t>~75,000</a:t>
+            </a:r>
+          </a:p>
+        </p:txBody>
+      </p:sp>
+      <p:sp>
+        <p:nvSpPr>
+          <p:cNvPr id="21" name="TextBox 20"/>
+          <p:cNvSpPr txBox="1"/>
+          <p:nvPr/>
+        </p:nvSpPr>
+        <p:spPr>
+          <a:xfrm>
+            <a:off x="4472787" y="4709160"/>
+            <a:ext cx="3246120" cy="274320"/>
+          </a:xfrm>
+          <a:prstGeom prst="rect">
+            <a:avLst/>
+          </a:prstGeom>
+          <a:noFill/>
+        </p:spPr>
+        <p:txBody>
+          <a:bodyPr wrap="square" lIns="0" rIns="0" tIns="0" bIns="0" anchor="t">
+            <a:spAutoFit/>
+          </a:bodyPr>
+          <a:lstStyle/>
+          <a:p>
+            <a:pPr algn="l">
+              <a:lnSpc>
+                <a:spcPct val="140000"/>
+              </a:lnSpc>
+            </a:pPr>
+            <a:r>
+              <a:rPr sz="800" b="0">
                 <a:solidFill>
                   <a:srgbClr val="5A5A5A"/>
                 </a:solidFill>
                 <a:latin typeface="Calibri"/>
               </a:rPr>
-              <a:t>Final usable training rows</a:t>
-            </a:r>
-          </a:p>
-        </p:txBody>
-      </p:sp>
-      <p:sp>
-        <p:nvSpPr>
-          <p:cNvPr id="11" name="Rounded Rectangle 10"/>
+              <a:t>ROWS</a:t>
+            </a:r>
+          </a:p>
+        </p:txBody>
+      </p:sp>
+      <p:sp>
+        <p:nvSpPr>
+          <p:cNvPr id="22" name="TextBox 21"/>
+          <p:cNvSpPr txBox="1"/>
+          <p:nvPr/>
+        </p:nvSpPr>
+        <p:spPr>
+          <a:xfrm>
+            <a:off x="4472787" y="5029200"/>
+            <a:ext cx="3246120" cy="274320"/>
+          </a:xfrm>
+          <a:prstGeom prst="rect">
+            <a:avLst/>
+          </a:prstGeom>
+          <a:noFill/>
+        </p:spPr>
+        <p:txBody>
+          <a:bodyPr wrap="square" lIns="0" rIns="0" tIns="0" bIns="0" anchor="t">
+            <a:spAutoFit/>
+          </a:bodyPr>
+          <a:lstStyle/>
+          <a:p>
+            <a:pPr algn="l">
+              <a:lnSpc>
+                <a:spcPct val="140000"/>
+              </a:lnSpc>
+            </a:pPr>
+            <a:r>
+              <a:rPr sz="800" b="1">
+                <a:solidFill>
+                  <a:srgbClr val="5A5A5A"/>
+                </a:solidFill>
+                <a:latin typeface="Calibri"/>
+              </a:rPr>
+              <a:t>TRAINS</a:t>
+            </a:r>
+          </a:p>
+        </p:txBody>
+      </p:sp>
+      <p:sp>
+        <p:nvSpPr>
+          <p:cNvPr id="23" name="TextBox 22"/>
+          <p:cNvSpPr txBox="1"/>
+          <p:nvPr/>
+        </p:nvSpPr>
+        <p:spPr>
+          <a:xfrm>
+            <a:off x="4472787" y="5230368"/>
+            <a:ext cx="3246120" cy="365760"/>
+          </a:xfrm>
+          <a:prstGeom prst="rect">
+            <a:avLst/>
+          </a:prstGeom>
+          <a:noFill/>
+        </p:spPr>
+        <p:txBody>
+          <a:bodyPr wrap="square" lIns="0" rIns="0" tIns="0" bIns="0" anchor="t">
+            <a:spAutoFit/>
+          </a:bodyPr>
+          <a:lstStyle/>
+          <a:p>
+            <a:pPr algn="l">
+              <a:lnSpc>
+                <a:spcPct val="140000"/>
+              </a:lnSpc>
+            </a:pPr>
+            <a:r>
+              <a:rPr sz="1100" b="1">
+                <a:solidFill>
+                  <a:srgbClr val="0E0E0E"/>
+                </a:solidFill>
+                <a:latin typeface="Calibri"/>
+              </a:rPr>
+              <a:t>Chart Reasoner · Phi-3 Mini</a:t>
+            </a:r>
+          </a:p>
+        </p:txBody>
+      </p:sp>
+      <p:sp>
+        <p:nvSpPr>
+          <p:cNvPr id="24" name="TextBox 23"/>
+          <p:cNvSpPr txBox="1"/>
+          <p:nvPr/>
+        </p:nvSpPr>
+        <p:spPr>
+          <a:xfrm>
+            <a:off x="4472787" y="5532120"/>
+            <a:ext cx="3246120" cy="457200"/>
+          </a:xfrm>
+          <a:prstGeom prst="rect">
+            <a:avLst/>
+          </a:prstGeom>
+          <a:noFill/>
+        </p:spPr>
+        <p:txBody>
+          <a:bodyPr wrap="square" lIns="0" rIns="0" tIns="0" bIns="0" anchor="t">
+            <a:spAutoFit/>
+          </a:bodyPr>
+          <a:lstStyle/>
+          <a:p>
+            <a:pPr algn="l">
+              <a:lnSpc>
+                <a:spcPct val="140000"/>
+              </a:lnSpc>
+            </a:pPr>
+            <a:r>
+              <a:rPr sz="1000" b="0">
+                <a:solidFill>
+                  <a:srgbClr val="0E0E0E"/>
+                </a:solidFill>
+                <a:latin typeface="Calibri"/>
+              </a:rPr>
+              <a:t>Question + SQL results → JSON chart spec (type, axes, title).</a:t>
+            </a:r>
+          </a:p>
+        </p:txBody>
+      </p:sp>
+      <p:sp>
+        <p:nvSpPr>
+          <p:cNvPr id="25" name="TextBox 24"/>
+          <p:cNvSpPr txBox="1"/>
+          <p:nvPr/>
+        </p:nvSpPr>
+        <p:spPr>
+          <a:xfrm>
+            <a:off x="4472787" y="5897880"/>
+            <a:ext cx="3246120" cy="457200"/>
+          </a:xfrm>
+          <a:prstGeom prst="rect">
+            <a:avLst/>
+          </a:prstGeom>
+          <a:noFill/>
+        </p:spPr>
+        <p:txBody>
+          <a:bodyPr wrap="square" lIns="0" rIns="0" tIns="0" bIns="0" anchor="t">
+            <a:spAutoFit/>
+          </a:bodyPr>
+          <a:lstStyle/>
+          <a:p>
+            <a:pPr algn="l">
+              <a:lnSpc>
+                <a:spcPct val="135000"/>
+              </a:lnSpc>
+            </a:pPr>
+            <a:r>
+              <a:rPr sz="900" b="0">
+                <a:solidFill>
+                  <a:srgbClr val="5A5A5A"/>
+                </a:solidFill>
+                <a:latin typeface="Calibri"/>
+              </a:rPr>
+              <a:t>25k real NL/chart pairs from nvBench + 50k pairs synthesized via GPT-4.1-nano knowledge distillation over the SQL corpus.</a:t>
+            </a:r>
+          </a:p>
+        </p:txBody>
+      </p:sp>
+      <p:sp>
+        <p:nvSpPr>
+          <p:cNvPr id="26" name="Rounded Rectangle 25"/>
           <p:cNvSpPr/>
           <p:nvPr/>
         </p:nvSpPr>
         <p:spPr>
           <a:xfrm>
-            <a:off x="8084667" y="2011680"/>
-            <a:ext cx="3520440" cy="1097280"/>
+            <a:off x="8084667" y="3200400"/>
+            <a:ext cx="3611880" cy="3017520"/>
           </a:xfrm>
           <a:prstGeom prst="roundRect">
             <a:avLst>
@@ -5377,146 +5970,24 @@
       </p:sp>
       <p:sp>
         <p:nvSpPr>
-          <p:cNvPr id="12" name="TextBox 11"/>
-          <p:cNvSpPr txBox="1"/>
-          <p:nvPr/>
-        </p:nvSpPr>
-        <p:spPr>
-          <a:xfrm>
-            <a:off x="8084667" y="2148840"/>
-            <a:ext cx="3520440" cy="548640"/>
-          </a:xfrm>
-          <a:prstGeom prst="rect">
-            <a:avLst/>
-          </a:prstGeom>
-          <a:noFill/>
-        </p:spPr>
-        <p:txBody>
-          <a:bodyPr wrap="square" lIns="0" rIns="0" tIns="0" bIns="0" anchor="t">
-            <a:spAutoFit/>
-          </a:bodyPr>
-          <a:lstStyle/>
-          <a:p>
-            <a:pPr algn="ctr">
-              <a:lnSpc>
-                <a:spcPct val="140000"/>
-              </a:lnSpc>
-            </a:pPr>
-            <a:r>
-              <a:rPr sz="3600" b="1">
-                <a:solidFill>
-                  <a:srgbClr val="0E0E0E"/>
-                </a:solidFill>
-                <a:latin typeface="Calibri"/>
-              </a:rPr>
-              <a:t>3</a:t>
-            </a:r>
-          </a:p>
-        </p:txBody>
-      </p:sp>
-      <p:sp>
-        <p:nvSpPr>
-          <p:cNvPr id="13" name="TextBox 12"/>
-          <p:cNvSpPr txBox="1"/>
-          <p:nvPr/>
-        </p:nvSpPr>
-        <p:spPr>
-          <a:xfrm>
-            <a:off x="8084667" y="2697480"/>
-            <a:ext cx="3520440" cy="365760"/>
-          </a:xfrm>
-          <a:prstGeom prst="rect">
-            <a:avLst/>
-          </a:prstGeom>
-          <a:noFill/>
-        </p:spPr>
-        <p:txBody>
-          <a:bodyPr wrap="square" lIns="0" rIns="0" tIns="0" bIns="0" anchor="t">
-            <a:spAutoFit/>
-          </a:bodyPr>
-          <a:lstStyle/>
-          <a:p>
-            <a:pPr algn="ctr">
-              <a:lnSpc>
-                <a:spcPct val="140000"/>
-              </a:lnSpc>
-            </a:pPr>
-            <a:r>
-              <a:rPr sz="1100" b="0">
-                <a:solidFill>
-                  <a:srgbClr val="5A5A5A"/>
-                </a:solidFill>
-                <a:latin typeface="Calibri"/>
-              </a:rPr>
-              <a:t>Task-specific datasets built</a:t>
-            </a:r>
-          </a:p>
-        </p:txBody>
-      </p:sp>
-      <p:sp>
-        <p:nvSpPr>
-          <p:cNvPr id="14" name="TextBox 13"/>
-          <p:cNvSpPr txBox="1"/>
-          <p:nvPr/>
-        </p:nvSpPr>
-        <p:spPr>
-          <a:xfrm>
-            <a:off x="758952" y="3337560"/>
-            <a:ext cx="10058400" cy="274320"/>
-          </a:xfrm>
-          <a:prstGeom prst="rect">
-            <a:avLst/>
-          </a:prstGeom>
-          <a:noFill/>
-        </p:spPr>
-        <p:txBody>
-          <a:bodyPr wrap="square" lIns="0" rIns="0" tIns="0" bIns="0" anchor="t">
-            <a:spAutoFit/>
-          </a:bodyPr>
-          <a:lstStyle/>
-          <a:p>
-            <a:pPr algn="l">
-              <a:lnSpc>
-                <a:spcPct val="140000"/>
-              </a:lnSpc>
-            </a:pPr>
-            <a:r>
-              <a:rPr sz="1000" b="1">
-                <a:solidFill>
-                  <a:srgbClr val="5A5A5A"/>
-                </a:solidFill>
-                <a:latin typeface="Calibri"/>
-              </a:rPr>
-              <a:t>PIPELINE — REPRODUCIBLE VIA UV SCRIPTS IN training/data_pipelines/</a:t>
-            </a:r>
-          </a:p>
-        </p:txBody>
-      </p:sp>
-      <p:sp>
-        <p:nvSpPr>
-          <p:cNvPr id="15" name="Rounded Rectangle 14"/>
+          <p:cNvPr id="27" name="Rectangle 26"/>
           <p:cNvSpPr/>
           <p:nvPr/>
         </p:nvSpPr>
         <p:spPr>
           <a:xfrm>
-            <a:off x="737463" y="3657600"/>
-            <a:ext cx="2011680" cy="1005840"/>
-          </a:xfrm>
-          <a:prstGeom prst="roundRect">
-            <a:avLst>
-              <a:gd name="adj" fmla="val 8000"/>
-            </a:avLst>
+            <a:off x="8267547" y="3364992"/>
+            <a:ext cx="365760" cy="45720"/>
+          </a:xfrm>
+          <a:prstGeom prst="rect">
+            <a:avLst/>
           </a:prstGeom>
           <a:solidFill>
-            <a:srgbClr val="FFFFFF"/>
+            <a:srgbClr val="C96442"/>
           </a:solidFill>
-          <a:ln w="9525">
-            <a:solidFill>
-              <a:srgbClr val="E5E5E5"/>
-            </a:solidFill>
+          <a:ln>
+            <a:noFill/>
           </a:ln>
-          <a:effectLst/>
         </p:spPr>
         <p:style>
           <a:lnRef idx="1">
@@ -5542,66 +6013,261 @@
       </p:sp>
       <p:sp>
         <p:nvSpPr>
-          <p:cNvPr id="16" name="TextBox 15"/>
-          <p:cNvSpPr txBox="1"/>
-          <p:nvPr/>
-        </p:nvSpPr>
-        <p:spPr>
-          <a:xfrm>
-            <a:off x="737463" y="3822191"/>
-            <a:ext cx="2011680" cy="365760"/>
-          </a:xfrm>
-          <a:prstGeom prst="rect">
-            <a:avLst/>
-          </a:prstGeom>
-          <a:noFill/>
-        </p:spPr>
-        <p:txBody>
-          <a:bodyPr wrap="square" lIns="0" rIns="0" tIns="0" bIns="0" anchor="t">
-            <a:spAutoFit/>
-          </a:bodyPr>
-          <a:lstStyle/>
-          <a:p>
-            <a:pPr algn="ctr">
-              <a:lnSpc>
-                <a:spcPct val="140000"/>
-              </a:lnSpc>
-            </a:pPr>
-            <a:r>
-              <a:rPr sz="1200" b="1">
+          <p:cNvPr id="28" name="TextBox 27"/>
+          <p:cNvSpPr txBox="1"/>
+          <p:nvPr/>
+        </p:nvSpPr>
+        <p:spPr>
+          <a:xfrm>
+            <a:off x="8267547" y="3493008"/>
+            <a:ext cx="3246120" cy="228600"/>
+          </a:xfrm>
+          <a:prstGeom prst="rect">
+            <a:avLst/>
+          </a:prstGeom>
+          <a:noFill/>
+        </p:spPr>
+        <p:txBody>
+          <a:bodyPr wrap="square" lIns="0" rIns="0" tIns="0" bIns="0" anchor="t">
+            <a:spAutoFit/>
+          </a:bodyPr>
+          <a:lstStyle/>
+          <a:p>
+            <a:pPr algn="l">
+              <a:lnSpc>
+                <a:spcPct val="140000"/>
+              </a:lnSpc>
+            </a:pPr>
+            <a:r>
+              <a:rPr sz="900" b="1">
+                <a:solidFill>
+                  <a:srgbClr val="C96442"/>
+                </a:solidFill>
+                <a:latin typeface="Calibri"/>
+              </a:rPr>
+              <a:t>DATASET · 03</a:t>
+            </a:r>
+          </a:p>
+        </p:txBody>
+      </p:sp>
+      <p:sp>
+        <p:nvSpPr>
+          <p:cNvPr id="29" name="TextBox 28"/>
+          <p:cNvSpPr txBox="1"/>
+          <p:nvPr/>
+        </p:nvSpPr>
+        <p:spPr>
+          <a:xfrm>
+            <a:off x="8267547" y="3749040"/>
+            <a:ext cx="3246120" cy="365760"/>
+          </a:xfrm>
+          <a:prstGeom prst="rect">
+            <a:avLst/>
+          </a:prstGeom>
+          <a:noFill/>
+        </p:spPr>
+        <p:txBody>
+          <a:bodyPr wrap="square" lIns="0" rIns="0" tIns="0" bIns="0" anchor="t">
+            <a:spAutoFit/>
+          </a:bodyPr>
+          <a:lstStyle/>
+          <a:p>
+            <a:pPr algn="l">
+              <a:lnSpc>
+                <a:spcPct val="140000"/>
+              </a:lnSpc>
+            </a:pPr>
+            <a:r>
+              <a:rPr sz="1400" b="1">
                 <a:solidFill>
                   <a:srgbClr val="0E0E0E"/>
                 </a:solidFill>
-                <a:latin typeface="Calibri"/>
-              </a:rPr>
-              <a:t>Source</a:t>
-            </a:r>
-          </a:p>
-        </p:txBody>
-      </p:sp>
-      <p:sp>
-        <p:nvSpPr>
-          <p:cNvPr id="17" name="TextBox 16"/>
-          <p:cNvSpPr txBox="1"/>
-          <p:nvPr/>
-        </p:nvSpPr>
-        <p:spPr>
-          <a:xfrm>
-            <a:off x="737463" y="4160520"/>
-            <a:ext cx="2011680" cy="457200"/>
-          </a:xfrm>
-          <a:prstGeom prst="rect">
-            <a:avLst/>
-          </a:prstGeom>
-          <a:noFill/>
-        </p:spPr>
-        <p:txBody>
-          <a:bodyPr wrap="square" lIns="0" rIns="0" tIns="0" bIns="0" anchor="t">
-            <a:spAutoFit/>
-          </a:bodyPr>
-          <a:lstStyle/>
-          <a:p>
-            <a:pPr algn="ctr">
+                <a:latin typeface="Menlo"/>
+              </a:rPr>
+              <a:t>svg-chart-render-v1</a:t>
+            </a:r>
+          </a:p>
+        </p:txBody>
+      </p:sp>
+      <p:sp>
+        <p:nvSpPr>
+          <p:cNvPr id="30" name="TextBox 29"/>
+          <p:cNvSpPr txBox="1"/>
+          <p:nvPr/>
+        </p:nvSpPr>
+        <p:spPr>
+          <a:xfrm>
+            <a:off x="8267547" y="4160520"/>
+            <a:ext cx="3246120" cy="548640"/>
+          </a:xfrm>
+          <a:prstGeom prst="rect">
+            <a:avLst/>
+          </a:prstGeom>
+          <a:noFill/>
+        </p:spPr>
+        <p:txBody>
+          <a:bodyPr wrap="square" lIns="0" rIns="0" tIns="0" bIns="0" anchor="t">
+            <a:spAutoFit/>
+          </a:bodyPr>
+          <a:lstStyle/>
+          <a:p>
+            <a:pPr algn="l">
+              <a:lnSpc>
+                <a:spcPct val="140000"/>
+              </a:lnSpc>
+            </a:pPr>
+            <a:r>
+              <a:rPr sz="2800" b="1">
+                <a:solidFill>
+                  <a:srgbClr val="0E0E0E"/>
+                </a:solidFill>
+                <a:latin typeface="Calibri"/>
+              </a:rPr>
+              <a:t>~25,000</a:t>
+            </a:r>
+          </a:p>
+        </p:txBody>
+      </p:sp>
+      <p:sp>
+        <p:nvSpPr>
+          <p:cNvPr id="31" name="TextBox 30"/>
+          <p:cNvSpPr txBox="1"/>
+          <p:nvPr/>
+        </p:nvSpPr>
+        <p:spPr>
+          <a:xfrm>
+            <a:off x="8267547" y="4709160"/>
+            <a:ext cx="3246120" cy="274320"/>
+          </a:xfrm>
+          <a:prstGeom prst="rect">
+            <a:avLst/>
+          </a:prstGeom>
+          <a:noFill/>
+        </p:spPr>
+        <p:txBody>
+          <a:bodyPr wrap="square" lIns="0" rIns="0" tIns="0" bIns="0" anchor="t">
+            <a:spAutoFit/>
+          </a:bodyPr>
+          <a:lstStyle/>
+          <a:p>
+            <a:pPr algn="l">
+              <a:lnSpc>
+                <a:spcPct val="140000"/>
+              </a:lnSpc>
+            </a:pPr>
+            <a:r>
+              <a:rPr sz="800" b="0">
+                <a:solidFill>
+                  <a:srgbClr val="5A5A5A"/>
+                </a:solidFill>
+                <a:latin typeface="Calibri"/>
+              </a:rPr>
+              <a:t>ROWS</a:t>
+            </a:r>
+          </a:p>
+        </p:txBody>
+      </p:sp>
+      <p:sp>
+        <p:nvSpPr>
+          <p:cNvPr id="32" name="TextBox 31"/>
+          <p:cNvSpPr txBox="1"/>
+          <p:nvPr/>
+        </p:nvSpPr>
+        <p:spPr>
+          <a:xfrm>
+            <a:off x="8267547" y="5029200"/>
+            <a:ext cx="3246120" cy="274320"/>
+          </a:xfrm>
+          <a:prstGeom prst="rect">
+            <a:avLst/>
+          </a:prstGeom>
+          <a:noFill/>
+        </p:spPr>
+        <p:txBody>
+          <a:bodyPr wrap="square" lIns="0" rIns="0" tIns="0" bIns="0" anchor="t">
+            <a:spAutoFit/>
+          </a:bodyPr>
+          <a:lstStyle/>
+          <a:p>
+            <a:pPr algn="l">
+              <a:lnSpc>
+                <a:spcPct val="140000"/>
+              </a:lnSpc>
+            </a:pPr>
+            <a:r>
+              <a:rPr sz="800" b="1">
+                <a:solidFill>
+                  <a:srgbClr val="5A5A5A"/>
+                </a:solidFill>
+                <a:latin typeface="Calibri"/>
+              </a:rPr>
+              <a:t>TRAINS</a:t>
+            </a:r>
+          </a:p>
+        </p:txBody>
+      </p:sp>
+      <p:sp>
+        <p:nvSpPr>
+          <p:cNvPr id="33" name="TextBox 32"/>
+          <p:cNvSpPr txBox="1"/>
+          <p:nvPr/>
+        </p:nvSpPr>
+        <p:spPr>
+          <a:xfrm>
+            <a:off x="8267547" y="5230368"/>
+            <a:ext cx="3246120" cy="365760"/>
+          </a:xfrm>
+          <a:prstGeom prst="rect">
+            <a:avLst/>
+          </a:prstGeom>
+          <a:noFill/>
+        </p:spPr>
+        <p:txBody>
+          <a:bodyPr wrap="square" lIns="0" rIns="0" tIns="0" bIns="0" anchor="t">
+            <a:spAutoFit/>
+          </a:bodyPr>
+          <a:lstStyle/>
+          <a:p>
+            <a:pPr algn="l">
+              <a:lnSpc>
+                <a:spcPct val="140000"/>
+              </a:lnSpc>
+            </a:pPr>
+            <a:r>
+              <a:rPr sz="1100" b="1">
+                <a:solidFill>
+                  <a:srgbClr val="0E0E0E"/>
+                </a:solidFill>
+                <a:latin typeface="Calibri"/>
+              </a:rPr>
+              <a:t>SVG Renderer · DeepSeek 1.3B</a:t>
+            </a:r>
+          </a:p>
+        </p:txBody>
+      </p:sp>
+      <p:sp>
+        <p:nvSpPr>
+          <p:cNvPr id="34" name="TextBox 33"/>
+          <p:cNvSpPr txBox="1"/>
+          <p:nvPr/>
+        </p:nvSpPr>
+        <p:spPr>
+          <a:xfrm>
+            <a:off x="8267547" y="5532120"/>
+            <a:ext cx="3246120" cy="457200"/>
+          </a:xfrm>
+          <a:prstGeom prst="rect">
+            <a:avLst/>
+          </a:prstGeom>
+          <a:noFill/>
+        </p:spPr>
+        <p:txBody>
+          <a:bodyPr wrap="square" lIns="0" rIns="0" tIns="0" bIns="0" anchor="t">
+            <a:spAutoFit/>
+          </a:bodyPr>
+          <a:lstStyle/>
+          <a:p>
+            <a:pPr algn="l">
               <a:lnSpc>
                 <a:spcPct val="140000"/>
               </a:lnSpc>
@@ -5609,785 +6275,89 @@
             <a:r>
               <a:rPr sz="1000" b="0">
                 <a:solidFill>
+                  <a:srgbClr val="0E0E0E"/>
+                </a:solidFill>
+                <a:latin typeface="Calibri"/>
+              </a:rPr>
+              <a:t>Chart spec + data sample → inline SVG markup.</a:t>
+            </a:r>
+          </a:p>
+        </p:txBody>
+      </p:sp>
+      <p:sp>
+        <p:nvSpPr>
+          <p:cNvPr id="35" name="TextBox 34"/>
+          <p:cNvSpPr txBox="1"/>
+          <p:nvPr/>
+        </p:nvSpPr>
+        <p:spPr>
+          <a:xfrm>
+            <a:off x="8267547" y="5897880"/>
+            <a:ext cx="3246120" cy="457200"/>
+          </a:xfrm>
+          <a:prstGeom prst="rect">
+            <a:avLst/>
+          </a:prstGeom>
+          <a:noFill/>
+        </p:spPr>
+        <p:txBody>
+          <a:bodyPr wrap="square" lIns="0" rIns="0" tIns="0" bIns="0" anchor="t">
+            <a:spAutoFit/>
+          </a:bodyPr>
+          <a:lstStyle/>
+          <a:p>
+            <a:pPr algn="l">
+              <a:lnSpc>
+                <a:spcPct val="135000"/>
+              </a:lnSpc>
+            </a:pPr>
+            <a:r>
+              <a:rPr sz="900" b="0">
+                <a:solidFill>
                   <a:srgbClr val="5A5A5A"/>
                 </a:solidFill>
                 <a:latin typeface="Calibri"/>
               </a:rPr>
-              <a:t>10 public
-datasets</a:t>
-            </a:r>
-          </a:p>
-        </p:txBody>
-      </p:sp>
-      <p:cxnSp>
-        <p:nvCxnSpPr>
-          <p:cNvPr id="18" name="Connector 17"/>
-          <p:cNvCxnSpPr/>
-          <p:nvPr/>
-        </p:nvCxnSpPr>
-        <p:spPr>
-          <a:xfrm>
-            <a:off x="2767431.5" y="4160520"/>
-            <a:ext cx="118872.0" cy="0"/>
-          </a:xfrm>
-          <a:prstGeom prst="line">
-            <a:avLst/>
-          </a:prstGeom>
-          <a:ln w="9525">
-            <a:solidFill>
-              <a:srgbClr val="5A5A5A"/>
-            </a:solidFill>
-          </a:ln>
-        </p:spPr>
-        <p:style>
-          <a:lnRef idx="2">
-            <a:schemeClr val="accent1"/>
-          </a:lnRef>
-          <a:fillRef idx="0">
-            <a:schemeClr val="accent1"/>
-          </a:fillRef>
-          <a:effectRef idx="1">
-            <a:schemeClr val="accent1"/>
-          </a:effectRef>
-          <a:fontRef idx="minor">
-            <a:schemeClr val="tx1"/>
-          </a:fontRef>
-        </p:style>
-      </p:cxnSp>
-      <p:sp>
-        <p:nvSpPr>
-          <p:cNvPr id="19" name="Rounded Rectangle 18"/>
-          <p:cNvSpPr/>
-          <p:nvPr/>
-        </p:nvSpPr>
-        <p:spPr>
-          <a:xfrm>
-            <a:off x="2913735" y="3657600"/>
-            <a:ext cx="2011680" cy="1005840"/>
-          </a:xfrm>
-          <a:prstGeom prst="roundRect">
-            <a:avLst>
-              <a:gd name="adj" fmla="val 8000"/>
-            </a:avLst>
-          </a:prstGeom>
-          <a:solidFill>
-            <a:srgbClr val="FFFFFF"/>
-          </a:solidFill>
-          <a:ln w="9525">
-            <a:solidFill>
-              <a:srgbClr val="E5E5E5"/>
-            </a:solidFill>
-          </a:ln>
-          <a:effectLst/>
-        </p:spPr>
-        <p:style>
-          <a:lnRef idx="1">
-            <a:schemeClr val="accent1"/>
-          </a:lnRef>
-          <a:fillRef idx="3">
-            <a:schemeClr val="accent1"/>
-          </a:fillRef>
-          <a:effectRef idx="2">
-            <a:schemeClr val="accent1"/>
-          </a:effectRef>
-          <a:fontRef idx="minor">
-            <a:schemeClr val="lt1"/>
-          </a:fontRef>
-        </p:style>
-        <p:txBody>
-          <a:bodyPr rtlCol="0" anchor="ctr"/>
-          <a:lstStyle/>
-          <a:p>
-            <a:pPr algn="ctr"/>
-          </a:p>
-        </p:txBody>
-      </p:sp>
-      <p:sp>
-        <p:nvSpPr>
-          <p:cNvPr id="20" name="TextBox 19"/>
-          <p:cNvSpPr txBox="1"/>
-          <p:nvPr/>
-        </p:nvSpPr>
-        <p:spPr>
-          <a:xfrm>
-            <a:off x="2913735" y="3822191"/>
-            <a:ext cx="2011680" cy="365760"/>
-          </a:xfrm>
-          <a:prstGeom prst="rect">
-            <a:avLst/>
-          </a:prstGeom>
-          <a:noFill/>
-        </p:spPr>
-        <p:txBody>
-          <a:bodyPr wrap="square" lIns="0" rIns="0" tIns="0" bIns="0" anchor="t">
-            <a:spAutoFit/>
-          </a:bodyPr>
-          <a:lstStyle/>
-          <a:p>
-            <a:pPr algn="ctr">
-              <a:lnSpc>
-                <a:spcPct val="140000"/>
-              </a:lnSpc>
-            </a:pPr>
-            <a:r>
-              <a:rPr sz="1200" b="1">
-                <a:solidFill>
-                  <a:srgbClr val="0E0E0E"/>
-                </a:solidFill>
-                <a:latin typeface="Calibri"/>
-              </a:rPr>
-              <a:t>Unify</a:t>
-            </a:r>
-          </a:p>
-        </p:txBody>
-      </p:sp>
-      <p:sp>
-        <p:nvSpPr>
-          <p:cNvPr id="21" name="TextBox 20"/>
-          <p:cNvSpPr txBox="1"/>
-          <p:nvPr/>
-        </p:nvSpPr>
-        <p:spPr>
-          <a:xfrm>
-            <a:off x="2913735" y="4160520"/>
-            <a:ext cx="2011680" cy="457200"/>
-          </a:xfrm>
-          <a:prstGeom prst="rect">
-            <a:avLst/>
-          </a:prstGeom>
-          <a:noFill/>
-        </p:spPr>
-        <p:txBody>
-          <a:bodyPr wrap="square" lIns="0" rIns="0" tIns="0" bIns="0" anchor="t">
-            <a:spAutoFit/>
-          </a:bodyPr>
-          <a:lstStyle/>
-          <a:p>
-            <a:pPr algn="ctr">
-              <a:lnSpc>
-                <a:spcPct val="140000"/>
-              </a:lnSpc>
-            </a:pPr>
-            <a:r>
-              <a:rPr sz="1000" b="0">
+              <a:t>nvBench charts re-rendered through matplotlib's SVG backend, plus chart-shaped SVGs filtered from the svgen-500k collection.</a:t>
+            </a:r>
+          </a:p>
+        </p:txBody>
+      </p:sp>
+      <p:sp>
+        <p:nvSpPr>
+          <p:cNvPr id="36" name="TextBox 35"/>
+          <p:cNvSpPr txBox="1"/>
+          <p:nvPr/>
+        </p:nvSpPr>
+        <p:spPr>
+          <a:xfrm>
+            <a:off x="758952" y="6400800"/>
+            <a:ext cx="10671048" cy="274320"/>
+          </a:xfrm>
+          <a:prstGeom prst="rect">
+            <a:avLst/>
+          </a:prstGeom>
+          <a:noFill/>
+        </p:spPr>
+        <p:txBody>
+          <a:bodyPr wrap="square" lIns="0" rIns="0" tIns="0" bIns="0" anchor="t">
+            <a:spAutoFit/>
+          </a:bodyPr>
+          <a:lstStyle/>
+          <a:p>
+            <a:pPr algn="l">
+              <a:lnSpc>
+                <a:spcPct val="140000"/>
+              </a:lnSpc>
+            </a:pPr>
+            <a:r>
+              <a:rPr sz="1100" b="0">
                 <a:solidFill>
                   <a:srgbClr val="5A5A5A"/>
                 </a:solidFill>
                 <a:latin typeface="Calibri"/>
               </a:rPr>
-              <a:t>7-column
-canonical</a:t>
-            </a:r>
-          </a:p>
-        </p:txBody>
-      </p:sp>
-      <p:cxnSp>
-        <p:nvCxnSpPr>
-          <p:cNvPr id="22" name="Connector 21"/>
-          <p:cNvCxnSpPr/>
-          <p:nvPr/>
-        </p:nvCxnSpPr>
-        <p:spPr>
-          <a:xfrm>
-            <a:off x="4943703.5" y="4160520"/>
-            <a:ext cx="118872.0" cy="0"/>
-          </a:xfrm>
-          <a:prstGeom prst="line">
-            <a:avLst/>
-          </a:prstGeom>
-          <a:ln w="9525">
-            <a:solidFill>
-              <a:srgbClr val="5A5A5A"/>
-            </a:solidFill>
-          </a:ln>
-        </p:spPr>
-        <p:style>
-          <a:lnRef idx="2">
-            <a:schemeClr val="accent1"/>
-          </a:lnRef>
-          <a:fillRef idx="0">
-            <a:schemeClr val="accent1"/>
-          </a:fillRef>
-          <a:effectRef idx="1">
-            <a:schemeClr val="accent1"/>
-          </a:effectRef>
-          <a:fontRef idx="minor">
-            <a:schemeClr val="tx1"/>
-          </a:fontRef>
-        </p:style>
-      </p:cxnSp>
-      <p:sp>
-        <p:nvSpPr>
-          <p:cNvPr id="23" name="Rounded Rectangle 22"/>
-          <p:cNvSpPr/>
-          <p:nvPr/>
-        </p:nvSpPr>
-        <p:spPr>
-          <a:xfrm>
-            <a:off x="5090007" y="3657600"/>
-            <a:ext cx="2011680" cy="1005840"/>
-          </a:xfrm>
-          <a:prstGeom prst="roundRect">
-            <a:avLst>
-              <a:gd name="adj" fmla="val 8000"/>
-            </a:avLst>
-          </a:prstGeom>
-          <a:solidFill>
-            <a:srgbClr val="FFFFFF"/>
-          </a:solidFill>
-          <a:ln w="9525">
-            <a:solidFill>
-              <a:srgbClr val="E5E5E5"/>
-            </a:solidFill>
-          </a:ln>
-          <a:effectLst/>
-        </p:spPr>
-        <p:style>
-          <a:lnRef idx="1">
-            <a:schemeClr val="accent1"/>
-          </a:lnRef>
-          <a:fillRef idx="3">
-            <a:schemeClr val="accent1"/>
-          </a:fillRef>
-          <a:effectRef idx="2">
-            <a:schemeClr val="accent1"/>
-          </a:effectRef>
-          <a:fontRef idx="minor">
-            <a:schemeClr val="lt1"/>
-          </a:fontRef>
-        </p:style>
-        <p:txBody>
-          <a:bodyPr rtlCol="0" anchor="ctr"/>
-          <a:lstStyle/>
-          <a:p>
-            <a:pPr algn="ctr"/>
-          </a:p>
-        </p:txBody>
-      </p:sp>
-      <p:sp>
-        <p:nvSpPr>
-          <p:cNvPr id="24" name="TextBox 23"/>
-          <p:cNvSpPr txBox="1"/>
-          <p:nvPr/>
-        </p:nvSpPr>
-        <p:spPr>
-          <a:xfrm>
-            <a:off x="5090007" y="3822191"/>
-            <a:ext cx="2011680" cy="365760"/>
-          </a:xfrm>
-          <a:prstGeom prst="rect">
-            <a:avLst/>
-          </a:prstGeom>
-          <a:noFill/>
-        </p:spPr>
-        <p:txBody>
-          <a:bodyPr wrap="square" lIns="0" rIns="0" tIns="0" bIns="0" anchor="t">
-            <a:spAutoFit/>
-          </a:bodyPr>
-          <a:lstStyle/>
-          <a:p>
-            <a:pPr algn="ctr">
-              <a:lnSpc>
-                <a:spcPct val="140000"/>
-              </a:lnSpc>
-            </a:pPr>
-            <a:r>
-              <a:rPr sz="1200" b="1">
-                <a:solidFill>
-                  <a:srgbClr val="0E0E0E"/>
-                </a:solidFill>
-                <a:latin typeface="Calibri"/>
-              </a:rPr>
-              <a:t>Dedup</a:t>
-            </a:r>
-          </a:p>
-        </p:txBody>
-      </p:sp>
-      <p:sp>
-        <p:nvSpPr>
-          <p:cNvPr id="25" name="TextBox 24"/>
-          <p:cNvSpPr txBox="1"/>
-          <p:nvPr/>
-        </p:nvSpPr>
-        <p:spPr>
-          <a:xfrm>
-            <a:off x="5090007" y="4160520"/>
-            <a:ext cx="2011680" cy="457200"/>
-          </a:xfrm>
-          <a:prstGeom prst="rect">
-            <a:avLst/>
-          </a:prstGeom>
-          <a:noFill/>
-        </p:spPr>
-        <p:txBody>
-          <a:bodyPr wrap="square" lIns="0" rIns="0" tIns="0" bIns="0" anchor="t">
-            <a:spAutoFit/>
-          </a:bodyPr>
-          <a:lstStyle/>
-          <a:p>
-            <a:pPr algn="ctr">
-              <a:lnSpc>
-                <a:spcPct val="140000"/>
-              </a:lnSpc>
-            </a:pPr>
-            <a:r>
-              <a:rPr sz="1000" b="0">
-                <a:solidFill>
-                  <a:srgbClr val="5A5A5A"/>
-                </a:solidFill>
-                <a:latin typeface="Calibri"/>
-              </a:rPr>
-              <a:t>question
-hashing</a:t>
-            </a:r>
-          </a:p>
-        </p:txBody>
-      </p:sp>
-      <p:cxnSp>
-        <p:nvCxnSpPr>
-          <p:cNvPr id="26" name="Connector 25"/>
-          <p:cNvCxnSpPr/>
-          <p:nvPr/>
-        </p:nvCxnSpPr>
-        <p:spPr>
-          <a:xfrm>
-            <a:off x="7119975.5" y="4160520"/>
-            <a:ext cx="118872.0" cy="0"/>
-          </a:xfrm>
-          <a:prstGeom prst="line">
-            <a:avLst/>
-          </a:prstGeom>
-          <a:ln w="9525">
-            <a:solidFill>
-              <a:srgbClr val="5A5A5A"/>
-            </a:solidFill>
-          </a:ln>
-        </p:spPr>
-        <p:style>
-          <a:lnRef idx="2">
-            <a:schemeClr val="accent1"/>
-          </a:lnRef>
-          <a:fillRef idx="0">
-            <a:schemeClr val="accent1"/>
-          </a:fillRef>
-          <a:effectRef idx="1">
-            <a:schemeClr val="accent1"/>
-          </a:effectRef>
-          <a:fontRef idx="minor">
-            <a:schemeClr val="tx1"/>
-          </a:fontRef>
-        </p:style>
-      </p:cxnSp>
-      <p:sp>
-        <p:nvSpPr>
-          <p:cNvPr id="27" name="Rounded Rectangle 26"/>
-          <p:cNvSpPr/>
-          <p:nvPr/>
-        </p:nvSpPr>
-        <p:spPr>
-          <a:xfrm>
-            <a:off x="7266279" y="3657600"/>
-            <a:ext cx="2011680" cy="1005840"/>
-          </a:xfrm>
-          <a:prstGeom prst="roundRect">
-            <a:avLst>
-              <a:gd name="adj" fmla="val 8000"/>
-            </a:avLst>
-          </a:prstGeom>
-          <a:solidFill>
-            <a:srgbClr val="FFFFFF"/>
-          </a:solidFill>
-          <a:ln w="9525">
-            <a:solidFill>
-              <a:srgbClr val="E5E5E5"/>
-            </a:solidFill>
-          </a:ln>
-          <a:effectLst/>
-        </p:spPr>
-        <p:style>
-          <a:lnRef idx="1">
-            <a:schemeClr val="accent1"/>
-          </a:lnRef>
-          <a:fillRef idx="3">
-            <a:schemeClr val="accent1"/>
-          </a:fillRef>
-          <a:effectRef idx="2">
-            <a:schemeClr val="accent1"/>
-          </a:effectRef>
-          <a:fontRef idx="minor">
-            <a:schemeClr val="lt1"/>
-          </a:fontRef>
-        </p:style>
-        <p:txBody>
-          <a:bodyPr rtlCol="0" anchor="ctr"/>
-          <a:lstStyle/>
-          <a:p>
-            <a:pPr algn="ctr"/>
-          </a:p>
-        </p:txBody>
-      </p:sp>
-      <p:sp>
-        <p:nvSpPr>
-          <p:cNvPr id="28" name="TextBox 27"/>
-          <p:cNvSpPr txBox="1"/>
-          <p:nvPr/>
-        </p:nvSpPr>
-        <p:spPr>
-          <a:xfrm>
-            <a:off x="7266279" y="3822191"/>
-            <a:ext cx="2011680" cy="365760"/>
-          </a:xfrm>
-          <a:prstGeom prst="rect">
-            <a:avLst/>
-          </a:prstGeom>
-          <a:noFill/>
-        </p:spPr>
-        <p:txBody>
-          <a:bodyPr wrap="square" lIns="0" rIns="0" tIns="0" bIns="0" anchor="t">
-            <a:spAutoFit/>
-          </a:bodyPr>
-          <a:lstStyle/>
-          <a:p>
-            <a:pPr algn="ctr">
-              <a:lnSpc>
-                <a:spcPct val="140000"/>
-              </a:lnSpc>
-            </a:pPr>
-            <a:r>
-              <a:rPr sz="1200" b="1">
-                <a:solidFill>
-                  <a:srgbClr val="0E0E0E"/>
-                </a:solidFill>
-                <a:latin typeface="Calibri"/>
-              </a:rPr>
-              <a:t>Filter</a:t>
-            </a:r>
-          </a:p>
-        </p:txBody>
-      </p:sp>
-      <p:sp>
-        <p:nvSpPr>
-          <p:cNvPr id="29" name="TextBox 28"/>
-          <p:cNvSpPr txBox="1"/>
-          <p:nvPr/>
-        </p:nvSpPr>
-        <p:spPr>
-          <a:xfrm>
-            <a:off x="7266279" y="4160520"/>
-            <a:ext cx="2011680" cy="457200"/>
-          </a:xfrm>
-          <a:prstGeom prst="rect">
-            <a:avLst/>
-          </a:prstGeom>
-          <a:noFill/>
-        </p:spPr>
-        <p:txBody>
-          <a:bodyPr wrap="square" lIns="0" rIns="0" tIns="0" bIns="0" anchor="t">
-            <a:spAutoFit/>
-          </a:bodyPr>
-          <a:lstStyle/>
-          <a:p>
-            <a:pPr algn="ctr">
-              <a:lnSpc>
-                <a:spcPct val="140000"/>
-              </a:lnSpc>
-            </a:pPr>
-            <a:r>
-              <a:rPr sz="1000" b="0">
-                <a:solidFill>
-                  <a:srgbClr val="5A5A5A"/>
-                </a:solidFill>
-                <a:latin typeface="Calibri"/>
-              </a:rPr>
-              <a:t>≤ 1024
-tokens</a:t>
-            </a:r>
-          </a:p>
-        </p:txBody>
-      </p:sp>
-      <p:cxnSp>
-        <p:nvCxnSpPr>
-          <p:cNvPr id="30" name="Connector 29"/>
-          <p:cNvCxnSpPr/>
-          <p:nvPr/>
-        </p:nvCxnSpPr>
-        <p:spPr>
-          <a:xfrm>
-            <a:off x="9296247.5" y="4160520"/>
-            <a:ext cx="118872.0" cy="0"/>
-          </a:xfrm>
-          <a:prstGeom prst="line">
-            <a:avLst/>
-          </a:prstGeom>
-          <a:ln w="9525">
-            <a:solidFill>
-              <a:srgbClr val="5A5A5A"/>
-            </a:solidFill>
-          </a:ln>
-        </p:spPr>
-        <p:style>
-          <a:lnRef idx="2">
-            <a:schemeClr val="accent1"/>
-          </a:lnRef>
-          <a:fillRef idx="0">
-            <a:schemeClr val="accent1"/>
-          </a:fillRef>
-          <a:effectRef idx="1">
-            <a:schemeClr val="accent1"/>
-          </a:effectRef>
-          <a:fontRef idx="minor">
-            <a:schemeClr val="tx1"/>
-          </a:fontRef>
-        </p:style>
-      </p:cxnSp>
-      <p:sp>
-        <p:nvSpPr>
-          <p:cNvPr id="31" name="Rounded Rectangle 30"/>
-          <p:cNvSpPr/>
-          <p:nvPr/>
-        </p:nvSpPr>
-        <p:spPr>
-          <a:xfrm>
-            <a:off x="9442551" y="3657600"/>
-            <a:ext cx="2011680" cy="1005840"/>
-          </a:xfrm>
-          <a:prstGeom prst="roundRect">
-            <a:avLst>
-              <a:gd name="adj" fmla="val 8000"/>
-            </a:avLst>
-          </a:prstGeom>
-          <a:solidFill>
-            <a:srgbClr val="FFFFFF"/>
-          </a:solidFill>
-          <a:ln w="19050">
-            <a:solidFill>
-              <a:srgbClr val="C96442"/>
-            </a:solidFill>
-          </a:ln>
-          <a:effectLst/>
-        </p:spPr>
-        <p:style>
-          <a:lnRef idx="1">
-            <a:schemeClr val="accent1"/>
-          </a:lnRef>
-          <a:fillRef idx="3">
-            <a:schemeClr val="accent1"/>
-          </a:fillRef>
-          <a:effectRef idx="2">
-            <a:schemeClr val="accent1"/>
-          </a:effectRef>
-          <a:fontRef idx="minor">
-            <a:schemeClr val="lt1"/>
-          </a:fontRef>
-        </p:style>
-        <p:txBody>
-          <a:bodyPr rtlCol="0" anchor="ctr"/>
-          <a:lstStyle/>
-          <a:p>
-            <a:pPr algn="ctr"/>
-          </a:p>
-        </p:txBody>
-      </p:sp>
-      <p:sp>
-        <p:nvSpPr>
-          <p:cNvPr id="32" name="TextBox 31"/>
-          <p:cNvSpPr txBox="1"/>
-          <p:nvPr/>
-        </p:nvSpPr>
-        <p:spPr>
-          <a:xfrm>
-            <a:off x="9442551" y="3822191"/>
-            <a:ext cx="2011680" cy="365760"/>
-          </a:xfrm>
-          <a:prstGeom prst="rect">
-            <a:avLst/>
-          </a:prstGeom>
-          <a:noFill/>
-        </p:spPr>
-        <p:txBody>
-          <a:bodyPr wrap="square" lIns="0" rIns="0" tIns="0" bIns="0" anchor="t">
-            <a:spAutoFit/>
-          </a:bodyPr>
-          <a:lstStyle/>
-          <a:p>
-            <a:pPr algn="ctr">
-              <a:lnSpc>
-                <a:spcPct val="140000"/>
-              </a:lnSpc>
-            </a:pPr>
-            <a:r>
-              <a:rPr sz="1200" b="1">
-                <a:solidFill>
-                  <a:srgbClr val="0E0E0E"/>
-                </a:solidFill>
-                <a:latin typeface="Calibri"/>
-              </a:rPr>
-              <a:t>Split</a:t>
-            </a:r>
-          </a:p>
-        </p:txBody>
-      </p:sp>
-      <p:sp>
-        <p:nvSpPr>
-          <p:cNvPr id="33" name="TextBox 32"/>
-          <p:cNvSpPr txBox="1"/>
-          <p:nvPr/>
-        </p:nvSpPr>
-        <p:spPr>
-          <a:xfrm>
-            <a:off x="9442551" y="4160520"/>
-            <a:ext cx="2011680" cy="457200"/>
-          </a:xfrm>
-          <a:prstGeom prst="rect">
-            <a:avLst/>
-          </a:prstGeom>
-          <a:noFill/>
-        </p:spPr>
-        <p:txBody>
-          <a:bodyPr wrap="square" lIns="0" rIns="0" tIns="0" bIns="0" anchor="t">
-            <a:spAutoFit/>
-          </a:bodyPr>
-          <a:lstStyle/>
-          <a:p>
-            <a:pPr algn="ctr">
-              <a:lnSpc>
-                <a:spcPct val="140000"/>
-              </a:lnSpc>
-            </a:pPr>
-            <a:r>
-              <a:rPr sz="1000" b="0">
-                <a:solidFill>
-                  <a:srgbClr val="5A5A5A"/>
-                </a:solidFill>
-                <a:latin typeface="Calibri"/>
-              </a:rPr>
-              <a:t>723k / 19k / 19k</a:t>
-            </a:r>
-          </a:p>
-        </p:txBody>
-      </p:sp>
-      <p:sp>
-        <p:nvSpPr>
-          <p:cNvPr id="34" name="Rounded Rectangle 33"/>
-          <p:cNvSpPr/>
-          <p:nvPr/>
-        </p:nvSpPr>
-        <p:spPr>
-          <a:xfrm>
-            <a:off x="586587" y="4983480"/>
-            <a:ext cx="3520440" cy="1188720"/>
-          </a:xfrm>
-          <a:prstGeom prst="roundRect">
-            <a:avLst>
-              <a:gd name="adj" fmla="val 8000"/>
-            </a:avLst>
-          </a:prstGeom>
-          <a:solidFill>
-            <a:srgbClr val="FFFFFF"/>
-          </a:solidFill>
-          <a:ln w="12700">
-            <a:solidFill>
-              <a:srgbClr val="C96442"/>
-            </a:solidFill>
-          </a:ln>
-          <a:effectLst/>
-        </p:spPr>
-        <p:style>
-          <a:lnRef idx="1">
-            <a:schemeClr val="accent1"/>
-          </a:lnRef>
-          <a:fillRef idx="3">
-            <a:schemeClr val="accent1"/>
-          </a:fillRef>
-          <a:effectRef idx="2">
-            <a:schemeClr val="accent1"/>
-          </a:effectRef>
-          <a:fontRef idx="minor">
-            <a:schemeClr val="lt1"/>
-          </a:fontRef>
-        </p:style>
-        <p:txBody>
-          <a:bodyPr rtlCol="0" anchor="ctr"/>
-          <a:lstStyle/>
-          <a:p>
-            <a:pPr algn="ctr"/>
-          </a:p>
-        </p:txBody>
-      </p:sp>
-      <p:sp>
-        <p:nvSpPr>
-          <p:cNvPr id="35" name="TextBox 34"/>
-          <p:cNvSpPr txBox="1"/>
-          <p:nvPr/>
-        </p:nvSpPr>
-        <p:spPr>
-          <a:xfrm>
-            <a:off x="769467" y="5120640"/>
-            <a:ext cx="3154680" cy="274320"/>
-          </a:xfrm>
-          <a:prstGeom prst="rect">
-            <a:avLst/>
-          </a:prstGeom>
-          <a:noFill/>
-        </p:spPr>
-        <p:txBody>
-          <a:bodyPr wrap="square" lIns="0" rIns="0" tIns="0" bIns="0" anchor="t">
-            <a:spAutoFit/>
-          </a:bodyPr>
-          <a:lstStyle/>
-          <a:p>
-            <a:pPr algn="l">
-              <a:lnSpc>
-                <a:spcPct val="140000"/>
-              </a:lnSpc>
-            </a:pPr>
-            <a:r>
-              <a:rPr sz="900" b="1">
-                <a:solidFill>
-                  <a:srgbClr val="C96442"/>
-                </a:solidFill>
-                <a:latin typeface="Calibri"/>
-              </a:rPr>
-              <a:t>DATASET · 01</a:t>
-            </a:r>
-          </a:p>
-        </p:txBody>
-      </p:sp>
-      <p:sp>
-        <p:nvSpPr>
-          <p:cNvPr id="36" name="TextBox 35"/>
-          <p:cNvSpPr txBox="1"/>
-          <p:nvPr/>
-        </p:nvSpPr>
-        <p:spPr>
-          <a:xfrm>
-            <a:off x="769467" y="5394960"/>
-            <a:ext cx="3154680" cy="365760"/>
-          </a:xfrm>
-          <a:prstGeom prst="rect">
-            <a:avLst/>
-          </a:prstGeom>
-          <a:noFill/>
-        </p:spPr>
-        <p:txBody>
-          <a:bodyPr wrap="square" lIns="0" rIns="0" tIns="0" bIns="0" anchor="t">
-            <a:spAutoFit/>
-          </a:bodyPr>
-          <a:lstStyle/>
-          <a:p>
-            <a:pPr algn="l">
-              <a:lnSpc>
-                <a:spcPct val="140000"/>
-              </a:lnSpc>
-            </a:pPr>
-            <a:r>
-              <a:rPr sz="1200" b="1">
-                <a:solidFill>
-                  <a:srgbClr val="0E0E0E"/>
-                </a:solidFill>
-                <a:latin typeface="Menlo"/>
-              </a:rPr>
-              <a:t>text-to-sql-mix-v2</a:t>
+              <a:t>All three published openly on Hugging Face Hub under permissive licenses (Apache-2.0, CC-BY-4.0).</a:t>
             </a:r>
           </a:p>
         </p:txBody>
@@ -6395,492 +6365,6 @@
       <p:sp>
         <p:nvSpPr>
           <p:cNvPr id="37" name="TextBox 36"/>
-          <p:cNvSpPr txBox="1"/>
-          <p:nvPr/>
-        </p:nvSpPr>
-        <p:spPr>
-          <a:xfrm>
-            <a:off x="769467" y="5715000"/>
-            <a:ext cx="3154680" cy="274320"/>
-          </a:xfrm>
-          <a:prstGeom prst="rect">
-            <a:avLst/>
-          </a:prstGeom>
-          <a:noFill/>
-        </p:spPr>
-        <p:txBody>
-          <a:bodyPr wrap="square" lIns="0" rIns="0" tIns="0" bIns="0" anchor="t">
-            <a:spAutoFit/>
-          </a:bodyPr>
-          <a:lstStyle/>
-          <a:p>
-            <a:pPr algn="l">
-              <a:lnSpc>
-                <a:spcPct val="140000"/>
-              </a:lnSpc>
-            </a:pPr>
-            <a:r>
-              <a:rPr sz="1100" b="0">
-                <a:solidFill>
-                  <a:srgbClr val="0E0E0E"/>
-                </a:solidFill>
-                <a:latin typeface="Calibri"/>
-              </a:rPr>
-              <a:t>761,155 rows</a:t>
-            </a:r>
-          </a:p>
-        </p:txBody>
-      </p:sp>
-      <p:sp>
-        <p:nvSpPr>
-          <p:cNvPr id="38" name="TextBox 37"/>
-          <p:cNvSpPr txBox="1"/>
-          <p:nvPr/>
-        </p:nvSpPr>
-        <p:spPr>
-          <a:xfrm>
-            <a:off x="769467" y="5943600"/>
-            <a:ext cx="3154680" cy="274320"/>
-          </a:xfrm>
-          <a:prstGeom prst="rect">
-            <a:avLst/>
-          </a:prstGeom>
-          <a:noFill/>
-        </p:spPr>
-        <p:txBody>
-          <a:bodyPr wrap="square" lIns="0" rIns="0" tIns="0" bIns="0" anchor="t">
-            <a:spAutoFit/>
-          </a:bodyPr>
-          <a:lstStyle/>
-          <a:p>
-            <a:pPr algn="l">
-              <a:lnSpc>
-                <a:spcPct val="140000"/>
-              </a:lnSpc>
-            </a:pPr>
-            <a:r>
-              <a:rPr sz="1000" b="0">
-                <a:solidFill>
-                  <a:srgbClr val="5A5A5A"/>
-                </a:solidFill>
-                <a:latin typeface="Calibri"/>
-              </a:rPr>
-              <a:t>10 public sources</a:t>
-            </a:r>
-          </a:p>
-        </p:txBody>
-      </p:sp>
-      <p:sp>
-        <p:nvSpPr>
-          <p:cNvPr id="39" name="Rounded Rectangle 38"/>
-          <p:cNvSpPr/>
-          <p:nvPr/>
-        </p:nvSpPr>
-        <p:spPr>
-          <a:xfrm>
-            <a:off x="4335627" y="4983480"/>
-            <a:ext cx="3520440" cy="1188720"/>
-          </a:xfrm>
-          <a:prstGeom prst="roundRect">
-            <a:avLst>
-              <a:gd name="adj" fmla="val 8000"/>
-            </a:avLst>
-          </a:prstGeom>
-          <a:solidFill>
-            <a:srgbClr val="FFFFFF"/>
-          </a:solidFill>
-          <a:ln w="12700">
-            <a:solidFill>
-              <a:srgbClr val="C96442"/>
-            </a:solidFill>
-          </a:ln>
-          <a:effectLst/>
-        </p:spPr>
-        <p:style>
-          <a:lnRef idx="1">
-            <a:schemeClr val="accent1"/>
-          </a:lnRef>
-          <a:fillRef idx="3">
-            <a:schemeClr val="accent1"/>
-          </a:fillRef>
-          <a:effectRef idx="2">
-            <a:schemeClr val="accent1"/>
-          </a:effectRef>
-          <a:fontRef idx="minor">
-            <a:schemeClr val="lt1"/>
-          </a:fontRef>
-        </p:style>
-        <p:txBody>
-          <a:bodyPr rtlCol="0" anchor="ctr"/>
-          <a:lstStyle/>
-          <a:p>
-            <a:pPr algn="ctr"/>
-          </a:p>
-        </p:txBody>
-      </p:sp>
-      <p:sp>
-        <p:nvSpPr>
-          <p:cNvPr id="40" name="TextBox 39"/>
-          <p:cNvSpPr txBox="1"/>
-          <p:nvPr/>
-        </p:nvSpPr>
-        <p:spPr>
-          <a:xfrm>
-            <a:off x="4518507" y="5120640"/>
-            <a:ext cx="3154680" cy="274320"/>
-          </a:xfrm>
-          <a:prstGeom prst="rect">
-            <a:avLst/>
-          </a:prstGeom>
-          <a:noFill/>
-        </p:spPr>
-        <p:txBody>
-          <a:bodyPr wrap="square" lIns="0" rIns="0" tIns="0" bIns="0" anchor="t">
-            <a:spAutoFit/>
-          </a:bodyPr>
-          <a:lstStyle/>
-          <a:p>
-            <a:pPr algn="l">
-              <a:lnSpc>
-                <a:spcPct val="140000"/>
-              </a:lnSpc>
-            </a:pPr>
-            <a:r>
-              <a:rPr sz="900" b="1">
-                <a:solidFill>
-                  <a:srgbClr val="C96442"/>
-                </a:solidFill>
-                <a:latin typeface="Calibri"/>
-              </a:rPr>
-              <a:t>DATASET · 02</a:t>
-            </a:r>
-          </a:p>
-        </p:txBody>
-      </p:sp>
-      <p:sp>
-        <p:nvSpPr>
-          <p:cNvPr id="41" name="TextBox 40"/>
-          <p:cNvSpPr txBox="1"/>
-          <p:nvPr/>
-        </p:nvSpPr>
-        <p:spPr>
-          <a:xfrm>
-            <a:off x="4518507" y="5394960"/>
-            <a:ext cx="3154680" cy="365760"/>
-          </a:xfrm>
-          <a:prstGeom prst="rect">
-            <a:avLst/>
-          </a:prstGeom>
-          <a:noFill/>
-        </p:spPr>
-        <p:txBody>
-          <a:bodyPr wrap="square" lIns="0" rIns="0" tIns="0" bIns="0" anchor="t">
-            <a:spAutoFit/>
-          </a:bodyPr>
-          <a:lstStyle/>
-          <a:p>
-            <a:pPr algn="l">
-              <a:lnSpc>
-                <a:spcPct val="140000"/>
-              </a:lnSpc>
-            </a:pPr>
-            <a:r>
-              <a:rPr sz="1200" b="1">
-                <a:solidFill>
-                  <a:srgbClr val="0E0E0E"/>
-                </a:solidFill>
-                <a:latin typeface="Menlo"/>
-              </a:rPr>
-              <a:t>chart-reasoning-mix-v1</a:t>
-            </a:r>
-          </a:p>
-        </p:txBody>
-      </p:sp>
-      <p:sp>
-        <p:nvSpPr>
-          <p:cNvPr id="42" name="TextBox 41"/>
-          <p:cNvSpPr txBox="1"/>
-          <p:nvPr/>
-        </p:nvSpPr>
-        <p:spPr>
-          <a:xfrm>
-            <a:off x="4518507" y="5715000"/>
-            <a:ext cx="3154680" cy="274320"/>
-          </a:xfrm>
-          <a:prstGeom prst="rect">
-            <a:avLst/>
-          </a:prstGeom>
-          <a:noFill/>
-        </p:spPr>
-        <p:txBody>
-          <a:bodyPr wrap="square" lIns="0" rIns="0" tIns="0" bIns="0" anchor="t">
-            <a:spAutoFit/>
-          </a:bodyPr>
-          <a:lstStyle/>
-          <a:p>
-            <a:pPr algn="l">
-              <a:lnSpc>
-                <a:spcPct val="140000"/>
-              </a:lnSpc>
-            </a:pPr>
-            <a:r>
-              <a:rPr sz="1100" b="0">
-                <a:solidFill>
-                  <a:srgbClr val="0E0E0E"/>
-                </a:solidFill>
-                <a:latin typeface="Calibri"/>
-              </a:rPr>
-              <a:t>~75,000 rows</a:t>
-            </a:r>
-          </a:p>
-        </p:txBody>
-      </p:sp>
-      <p:sp>
-        <p:nvSpPr>
-          <p:cNvPr id="43" name="TextBox 42"/>
-          <p:cNvSpPr txBox="1"/>
-          <p:nvPr/>
-        </p:nvSpPr>
-        <p:spPr>
-          <a:xfrm>
-            <a:off x="4518507" y="5943600"/>
-            <a:ext cx="3154680" cy="274320"/>
-          </a:xfrm>
-          <a:prstGeom prst="rect">
-            <a:avLst/>
-          </a:prstGeom>
-          <a:noFill/>
-        </p:spPr>
-        <p:txBody>
-          <a:bodyPr wrap="square" lIns="0" rIns="0" tIns="0" bIns="0" anchor="t">
-            <a:spAutoFit/>
-          </a:bodyPr>
-          <a:lstStyle/>
-          <a:p>
-            <a:pPr algn="l">
-              <a:lnSpc>
-                <a:spcPct val="140000"/>
-              </a:lnSpc>
-            </a:pPr>
-            <a:r>
-              <a:rPr sz="1000" b="0">
-                <a:solidFill>
-                  <a:srgbClr val="5A5A5A"/>
-                </a:solidFill>
-                <a:latin typeface="Calibri"/>
-              </a:rPr>
-              <a:t>nvBench + GPT-4.1-nano</a:t>
-            </a:r>
-          </a:p>
-        </p:txBody>
-      </p:sp>
-      <p:sp>
-        <p:nvSpPr>
-          <p:cNvPr id="44" name="Rounded Rectangle 43"/>
-          <p:cNvSpPr/>
-          <p:nvPr/>
-        </p:nvSpPr>
-        <p:spPr>
-          <a:xfrm>
-            <a:off x="8084667" y="4983480"/>
-            <a:ext cx="3520440" cy="1188720"/>
-          </a:xfrm>
-          <a:prstGeom prst="roundRect">
-            <a:avLst>
-              <a:gd name="adj" fmla="val 8000"/>
-            </a:avLst>
-          </a:prstGeom>
-          <a:solidFill>
-            <a:srgbClr val="FFFFFF"/>
-          </a:solidFill>
-          <a:ln w="12700">
-            <a:solidFill>
-              <a:srgbClr val="C96442"/>
-            </a:solidFill>
-          </a:ln>
-          <a:effectLst/>
-        </p:spPr>
-        <p:style>
-          <a:lnRef idx="1">
-            <a:schemeClr val="accent1"/>
-          </a:lnRef>
-          <a:fillRef idx="3">
-            <a:schemeClr val="accent1"/>
-          </a:fillRef>
-          <a:effectRef idx="2">
-            <a:schemeClr val="accent1"/>
-          </a:effectRef>
-          <a:fontRef idx="minor">
-            <a:schemeClr val="lt1"/>
-          </a:fontRef>
-        </p:style>
-        <p:txBody>
-          <a:bodyPr rtlCol="0" anchor="ctr"/>
-          <a:lstStyle/>
-          <a:p>
-            <a:pPr algn="ctr"/>
-          </a:p>
-        </p:txBody>
-      </p:sp>
-      <p:sp>
-        <p:nvSpPr>
-          <p:cNvPr id="45" name="TextBox 44"/>
-          <p:cNvSpPr txBox="1"/>
-          <p:nvPr/>
-        </p:nvSpPr>
-        <p:spPr>
-          <a:xfrm>
-            <a:off x="8267547" y="5120640"/>
-            <a:ext cx="3154680" cy="274320"/>
-          </a:xfrm>
-          <a:prstGeom prst="rect">
-            <a:avLst/>
-          </a:prstGeom>
-          <a:noFill/>
-        </p:spPr>
-        <p:txBody>
-          <a:bodyPr wrap="square" lIns="0" rIns="0" tIns="0" bIns="0" anchor="t">
-            <a:spAutoFit/>
-          </a:bodyPr>
-          <a:lstStyle/>
-          <a:p>
-            <a:pPr algn="l">
-              <a:lnSpc>
-                <a:spcPct val="140000"/>
-              </a:lnSpc>
-            </a:pPr>
-            <a:r>
-              <a:rPr sz="900" b="1">
-                <a:solidFill>
-                  <a:srgbClr val="C96442"/>
-                </a:solidFill>
-                <a:latin typeface="Calibri"/>
-              </a:rPr>
-              <a:t>DATASET · 03</a:t>
-            </a:r>
-          </a:p>
-        </p:txBody>
-      </p:sp>
-      <p:sp>
-        <p:nvSpPr>
-          <p:cNvPr id="46" name="TextBox 45"/>
-          <p:cNvSpPr txBox="1"/>
-          <p:nvPr/>
-        </p:nvSpPr>
-        <p:spPr>
-          <a:xfrm>
-            <a:off x="8267547" y="5394960"/>
-            <a:ext cx="3154680" cy="365760"/>
-          </a:xfrm>
-          <a:prstGeom prst="rect">
-            <a:avLst/>
-          </a:prstGeom>
-          <a:noFill/>
-        </p:spPr>
-        <p:txBody>
-          <a:bodyPr wrap="square" lIns="0" rIns="0" tIns="0" bIns="0" anchor="t">
-            <a:spAutoFit/>
-          </a:bodyPr>
-          <a:lstStyle/>
-          <a:p>
-            <a:pPr algn="l">
-              <a:lnSpc>
-                <a:spcPct val="140000"/>
-              </a:lnSpc>
-            </a:pPr>
-            <a:r>
-              <a:rPr sz="1200" b="1">
-                <a:solidFill>
-                  <a:srgbClr val="0E0E0E"/>
-                </a:solidFill>
-                <a:latin typeface="Menlo"/>
-              </a:rPr>
-              <a:t>svg-chart-render-v1</a:t>
-            </a:r>
-          </a:p>
-        </p:txBody>
-      </p:sp>
-      <p:sp>
-        <p:nvSpPr>
-          <p:cNvPr id="47" name="TextBox 46"/>
-          <p:cNvSpPr txBox="1"/>
-          <p:nvPr/>
-        </p:nvSpPr>
-        <p:spPr>
-          <a:xfrm>
-            <a:off x="8267547" y="5715000"/>
-            <a:ext cx="3154680" cy="274320"/>
-          </a:xfrm>
-          <a:prstGeom prst="rect">
-            <a:avLst/>
-          </a:prstGeom>
-          <a:noFill/>
-        </p:spPr>
-        <p:txBody>
-          <a:bodyPr wrap="square" lIns="0" rIns="0" tIns="0" bIns="0" anchor="t">
-            <a:spAutoFit/>
-          </a:bodyPr>
-          <a:lstStyle/>
-          <a:p>
-            <a:pPr algn="l">
-              <a:lnSpc>
-                <a:spcPct val="140000"/>
-              </a:lnSpc>
-            </a:pPr>
-            <a:r>
-              <a:rPr sz="1100" b="0">
-                <a:solidFill>
-                  <a:srgbClr val="0E0E0E"/>
-                </a:solidFill>
-                <a:latin typeface="Calibri"/>
-              </a:rPr>
-              <a:t>~25,000 rows</a:t>
-            </a:r>
-          </a:p>
-        </p:txBody>
-      </p:sp>
-      <p:sp>
-        <p:nvSpPr>
-          <p:cNvPr id="48" name="TextBox 47"/>
-          <p:cNvSpPr txBox="1"/>
-          <p:nvPr/>
-        </p:nvSpPr>
-        <p:spPr>
-          <a:xfrm>
-            <a:off x="8267547" y="5943600"/>
-            <a:ext cx="3154680" cy="274320"/>
-          </a:xfrm>
-          <a:prstGeom prst="rect">
-            <a:avLst/>
-          </a:prstGeom>
-          <a:noFill/>
-        </p:spPr>
-        <p:txBody>
-          <a:bodyPr wrap="square" lIns="0" rIns="0" tIns="0" bIns="0" anchor="t">
-            <a:spAutoFit/>
-          </a:bodyPr>
-          <a:lstStyle/>
-          <a:p>
-            <a:pPr algn="l">
-              <a:lnSpc>
-                <a:spcPct val="140000"/>
-              </a:lnSpc>
-            </a:pPr>
-            <a:r>
-              <a:rPr sz="1000" b="0">
-                <a:solidFill>
-                  <a:srgbClr val="5A5A5A"/>
-                </a:solidFill>
-                <a:latin typeface="Calibri"/>
-              </a:rPr>
-              <a:t>matplotlib SVG re-renders</a:t>
-            </a:r>
-          </a:p>
-        </p:txBody>
-      </p:sp>
-      <p:sp>
-        <p:nvSpPr>
-          <p:cNvPr id="49" name="TextBox 48"/>
           <p:cNvSpPr txBox="1"/>
           <p:nvPr/>
         </p:nvSpPr>
@@ -6912,14 +6396,14 @@
                 </a:solidFill>
                 <a:latin typeface="Calibri"/>
               </a:rPr>
-              <a:t>Data sourcing, curation, and datasets built</a:t>
-            </a:r>
-          </a:p>
-        </p:txBody>
-      </p:sp>
-      <p:sp>
-        <p:nvSpPr>
-          <p:cNvPr id="50" name="TextBox 49"/>
+              <a:t>Data — sourcing, curation, and three datasets</a:t>
+            </a:r>
+          </a:p>
+        </p:txBody>
+      </p:sp>
+      <p:sp>
+        <p:nvSpPr>
+          <p:cNvPr id="38" name="TextBox 37"/>
           <p:cNvSpPr txBox="1"/>
           <p:nvPr/>
         </p:nvSpPr>

</xml_diff>